<commit_message>
Update deck: multi-project auto-discovery + sprint-copilot repo references
</commit_message>
<xml_diff>
--- a/presentation/Sprint_Copilot.pptx
+++ b/presentation/Sprint_Copilot.pptx
@@ -3565,7 +3565,7 @@
                 </a:solidFill>
                 <a:latin typeface="Consolas"/>
               </a:rPr>
-              <a:t>      penninti/worklog-ai</a:t>
+              <a:t>      penninti/sprint-copilot</a:t>
             </a:r>
           </a:p>
         </p:txBody>
@@ -4597,7 +4597,7 @@
                 </a:solidFill>
                 <a:latin typeface="Segoe UI"/>
               </a:rPr>
-              <a:t>); the agent does the rest.</a:t>
+              <a:t>); the agent does the rest — automatically across every Jira project, so new boards just show up.</a:t>
             </a:r>
           </a:p>
         </p:txBody>
@@ -4893,7 +4893,7 @@
                 </a:solidFill>
                 <a:latin typeface="Consolas"/>
               </a:rPr>
-              <a:t>03ca272f  →  github.com/penninti/worklog-ai/commit/03ca272f</a:t>
+              <a:t>03ca272f  →  github.com/penninti/sprint-copilot/commit/03ca272f</a:t>
             </a:r>
           </a:p>
         </p:txBody>
@@ -5817,7 +5817,7 @@
                 </a:solidFill>
                 <a:latin typeface="Segoe UI"/>
               </a:rPr>
-              <a:t>reads tickets · moves them · comments</a:t>
+              <a:t>reads all projects · moves · comments</a:t>
             </a:r>
           </a:p>
           <a:p>

</xml_diff>